<commit_message>
docs(slides): update April_End_Report.pptx — Phase 1-4 naming + reduce line spacing to fix overflow
</commit_message>
<xml_diff>
--- a/docs/slides/April_End_Report.pptx
+++ b/docs/slides/April_End_Report.pptx
@@ -863,7 +863,7 @@
           <a:lstStyle/>
           <a:p>
             <a:r>
-              <a:t>我们在 40 天内经历了 3 个阶段和 4 次跃迁。v1 是 StockTransformer 路线，本地评分 0.0642；v2a 首次引入三模型 ensemble，87 天 rolling 首次拿到 t = +4.78 的硬证据；v2b 切换到 LGB-only 单模型，主动放弃理论上限换跨平台 deterministic，rolling 扩到 213 天得到 t = +12；v2c 是今天上午的 W1 防守补丁。注意核心模式：每次撤回的都是「当时最高分方案」，不是失败方案——撤回的动机都是发现了更严重的风险。</a:t>
+              <a:t>我们在 40 天内经历了 3 个阶段和 4 次跃迁。Phase 1 是 StockTransformer 路线，本地评分 0.0642；Phase 2 首次引入三模型 ensemble，87 天 rolling 首次拿到 t = +4.78 的硬证据；Phase 3 切换到 LGB-only 单模型（Phase 3），主动放弃理论上限换跨平台 deterministic，rolling 扩到 213 天得到 t = +12；Phase 4 是今天上午的 W1 防守补丁。注意核心模式：每次撤回的都是「当时最高分方案」，不是失败方案——撤回的动机都是发现了更严重的风险。</a:t>
             </a:r>
           </a:p>
         </p:txBody>
@@ -1003,7 +1003,7 @@
           <a:lstStyle/>
           <a:p>
             <a:r>
-              <a:t>v1 阶段的问题在于：本地 0.064 只在 30 天窗口验证，可能是过拟合；StockTransformer 跨平台 CUDA 非确定性导致 5 次推理分差 0.17，远超提升幅度；训练 6.3 小时，没有多 seed 的预算余地。v2a 做了三项工业化：Qlib 标准因子 + 严格 walk-forward CV + 三模型集成。首次在 87 天 rolling 上拿到 t = +4.78 的硬证据。但 holdout 搜出的最优权重暴露了问题——90% 权重都给了 MASTER，所谓的「三模型 ensemble」实质上是 MASTER 单模型在做主导。这个发现直接推动了第二次跃迁。</a:t>
+              <a:t>Phase 1 阶段的问题在于：本地 0.064 只在 30 天窗口验证，可能是过拟合；StockTransformer 跨平台 CUDA 非确定性导致 5 次推理分差 0.17，远超提升幅度；训练 6.3 小时，没有多 seed 的预算余地。Phase 2 做了三项工业化：Qlib 标准因子 + 严格 walk-forward CV + 三模型集成。首次在 87 天 rolling 上拿到 t = +4.78 的硬证据。但 holdout 搜出的最优权重暴露了问题——90% 权重都给了 MASTER，所谓的「三模型 ensemble」实质上是 MASTER 单模型在做主导。这个发现直接推动了第二次跃迁。</a:t>
             </a:r>
           </a:p>
         </p:txBody>
@@ -1073,7 +1073,7 @@
           <a:lstStyle/>
           <a:p>
             <a:r>
-              <a:t>第二次跃迁的核心是一个艰难的权衡——主动放弃当时最高分的方案。观察：MASTER attention 在 4060、5090、Windows 上 5 次推理输出不一致，直接违反赛规「两次推理 MD5 一致」硬约束。同时训练预算已用 79%。决策：保留 v2a 的全部基础设施（特征、CV、中性化、tradability），只换模型层——从三模型 ensemble 切换到单 LightGBM × 3 seeds 平均，并新增 deterministic_top_k。结果：训练时长降到 8 分钟，加速 47 倍；跨平台 5 次 MD5 完全一致；用省下的算力把 rolling 窗口扩到 213 天；最终 +2.41%，t = +12。事后看，我们交出的不是理论上限的一点，而是伪集成的不稳健性——这是 net positive 的决策。</a:t>
+              <a:t>第二次跃迁的核心是一个艰难的权衡——主动放弃当时最高分的方案。观察：MASTER attention 在 4060、5090、Windows 上 5 次推理输出不一致，直接违反赛规「两次推理 MD5 一致」硬约束。同时训练预算已用 79%。决策：保留 Phase 2 的全部基础设施（特征、CV、中性化、tradability），只换模型层——从三模型 ensemble 切换到单 LightGBM × 3 seeds 平均，并新增 deterministic_top_k。结果：训练时长降到 8 分钟，加速 47 倍；跨平台 5 次 MD5 完全一致；用省下的算力把 rolling 窗口扩到 213 天；最终 +2.41%，t = +12。事后看，我们交出的不是理论上限的一点，而是伪集成的不稳健性——这是 net positive 的决策。</a:t>
             </a:r>
           </a:p>
         </p:txBody>
@@ -10665,7 +10665,7 @@
                 </a:solidFill>
                 <a:latin typeface="Times New Roman"/>
               </a:rPr>
-              <a:t>v1</a:t>
+              <a:t>Phase 1</a:t>
             </a:r>
           </a:p>
         </p:txBody>
@@ -10718,26 +10718,26 @@
         <p:spPr>
           <a:xfrm>
             <a:off x="731520" y="4297680"/>
-            <a:ext cx="2514600" cy="457200"/>
-          </a:xfrm>
-          <a:prstGeom prst="rect">
-            <a:avLst/>
-          </a:prstGeom>
-          <a:noFill/>
-        </p:spPr>
-        <p:txBody>
-          <a:bodyPr wrap="square" lIns="0" rIns="0" tIns="0" bIns="0" anchor="t">
-            <a:spAutoFit/>
-          </a:bodyPr>
-          <a:lstStyle/>
-          <a:p>
-            <a:pPr algn="l">
-              <a:lnSpc>
-                <a:spcPct val="120000"/>
-              </a:lnSpc>
-            </a:pPr>
-            <a:r>
-              <a:rPr sz="2000" b="1" i="0">
+            <a:ext cx="2560320" cy="502920"/>
+          </a:xfrm>
+          <a:prstGeom prst="rect">
+            <a:avLst/>
+          </a:prstGeom>
+          <a:noFill/>
+        </p:spPr>
+        <p:txBody>
+          <a:bodyPr wrap="square" lIns="0" rIns="0" tIns="0" bIns="0" anchor="t">
+            <a:spAutoFit/>
+          </a:bodyPr>
+          <a:lstStyle/>
+          <a:p>
+            <a:pPr algn="l">
+              <a:lnSpc>
+                <a:spcPct val="120000"/>
+              </a:lnSpc>
+            </a:pPr>
+            <a:r>
+              <a:rPr sz="1800" b="1" i="0">
                 <a:solidFill>
                   <a:srgbClr val="151D2E"/>
                 </a:solidFill>
@@ -10883,7 +10883,7 @@
                 </a:solidFill>
                 <a:latin typeface="Times New Roman"/>
               </a:rPr>
-              <a:t>v2a</a:t>
+              <a:t>Phase 2</a:t>
             </a:r>
           </a:p>
         </p:txBody>
@@ -10936,26 +10936,26 @@
         <p:spPr>
           <a:xfrm>
             <a:off x="3429000" y="4297680"/>
-            <a:ext cx="2514600" cy="457200"/>
-          </a:xfrm>
-          <a:prstGeom prst="rect">
-            <a:avLst/>
-          </a:prstGeom>
-          <a:noFill/>
-        </p:spPr>
-        <p:txBody>
-          <a:bodyPr wrap="square" lIns="0" rIns="0" tIns="0" bIns="0" anchor="t">
-            <a:spAutoFit/>
-          </a:bodyPr>
-          <a:lstStyle/>
-          <a:p>
-            <a:pPr algn="l">
-              <a:lnSpc>
-                <a:spcPct val="120000"/>
-              </a:lnSpc>
-            </a:pPr>
-            <a:r>
-              <a:rPr sz="2000" b="1" i="0">
+            <a:ext cx="2560320" cy="502920"/>
+          </a:xfrm>
+          <a:prstGeom prst="rect">
+            <a:avLst/>
+          </a:prstGeom>
+          <a:noFill/>
+        </p:spPr>
+        <p:txBody>
+          <a:bodyPr wrap="square" lIns="0" rIns="0" tIns="0" bIns="0" anchor="t">
+            <a:spAutoFit/>
+          </a:bodyPr>
+          <a:lstStyle/>
+          <a:p>
+            <a:pPr algn="l">
+              <a:lnSpc>
+                <a:spcPct val="120000"/>
+              </a:lnSpc>
+            </a:pPr>
+            <a:r>
+              <a:rPr sz="1800" b="1" i="0">
                 <a:solidFill>
                   <a:srgbClr val="151D2E"/>
                 </a:solidFill>
@@ -11101,7 +11101,7 @@
                 </a:solidFill>
                 <a:latin typeface="Times New Roman"/>
               </a:rPr>
-              <a:t>v2b</a:t>
+              <a:t>Phase 3</a:t>
             </a:r>
           </a:p>
         </p:txBody>
@@ -11154,26 +11154,26 @@
         <p:spPr>
           <a:xfrm>
             <a:off x="6126480" y="4297680"/>
-            <a:ext cx="2514600" cy="457200"/>
-          </a:xfrm>
-          <a:prstGeom prst="rect">
-            <a:avLst/>
-          </a:prstGeom>
-          <a:noFill/>
-        </p:spPr>
-        <p:txBody>
-          <a:bodyPr wrap="square" lIns="0" rIns="0" tIns="0" bIns="0" anchor="t">
-            <a:spAutoFit/>
-          </a:bodyPr>
-          <a:lstStyle/>
-          <a:p>
-            <a:pPr algn="l">
-              <a:lnSpc>
-                <a:spcPct val="120000"/>
-              </a:lnSpc>
-            </a:pPr>
-            <a:r>
-              <a:rPr sz="2000" b="1" i="0">
+            <a:ext cx="2560320" cy="502920"/>
+          </a:xfrm>
+          <a:prstGeom prst="rect">
+            <a:avLst/>
+          </a:prstGeom>
+          <a:noFill/>
+        </p:spPr>
+        <p:txBody>
+          <a:bodyPr wrap="square" lIns="0" rIns="0" tIns="0" bIns="0" anchor="t">
+            <a:spAutoFit/>
+          </a:bodyPr>
+          <a:lstStyle/>
+          <a:p>
+            <a:pPr algn="l">
+              <a:lnSpc>
+                <a:spcPct val="120000"/>
+              </a:lnSpc>
+            </a:pPr>
+            <a:r>
+              <a:rPr sz="1800" b="1" i="0">
                 <a:solidFill>
                   <a:srgbClr val="151D2E"/>
                 </a:solidFill>
@@ -11319,7 +11319,7 @@
                 </a:solidFill>
                 <a:latin typeface="Times New Roman"/>
               </a:rPr>
-              <a:t>v2c</a:t>
+              <a:t>Phase 4</a:t>
             </a:r>
           </a:p>
         </p:txBody>
@@ -11372,32 +11372,32 @@
         <p:spPr>
           <a:xfrm>
             <a:off x="8823960" y="4297680"/>
-            <a:ext cx="2514600" cy="457200"/>
-          </a:xfrm>
-          <a:prstGeom prst="rect">
-            <a:avLst/>
-          </a:prstGeom>
-          <a:noFill/>
-        </p:spPr>
-        <p:txBody>
-          <a:bodyPr wrap="square" lIns="0" rIns="0" tIns="0" bIns="0" anchor="t">
-            <a:spAutoFit/>
-          </a:bodyPr>
-          <a:lstStyle/>
-          <a:p>
-            <a:pPr algn="l">
-              <a:lnSpc>
-                <a:spcPct val="120000"/>
-              </a:lnSpc>
-            </a:pPr>
-            <a:r>
-              <a:rPr sz="2000" b="1" i="0">
+            <a:ext cx="2560320" cy="502920"/>
+          </a:xfrm>
+          <a:prstGeom prst="rect">
+            <a:avLst/>
+          </a:prstGeom>
+          <a:noFill/>
+        </p:spPr>
+        <p:txBody>
+          <a:bodyPr wrap="square" lIns="0" rIns="0" tIns="0" bIns="0" anchor="t">
+            <a:spAutoFit/>
+          </a:bodyPr>
+          <a:lstStyle/>
+          <a:p>
+            <a:pPr algn="l">
+              <a:lnSpc>
+                <a:spcPct val="120000"/>
+              </a:lnSpc>
+            </a:pPr>
+            <a:r>
+              <a:rPr sz="1800" b="1" i="0">
                 <a:solidFill>
                   <a:srgbClr val="151D2E"/>
                 </a:solidFill>
                 <a:latin typeface="Microsoft YaHei"/>
               </a:rPr>
-              <a:t>W1 防守补丁 M10-3</a:t>
+              <a:t>Risk Containment M10-3</a:t>
             </a:r>
           </a:p>
         </p:txBody>
@@ -12916,7 +12916,7 @@
                 </a:solidFill>
                 <a:latin typeface="Microsoft YaHei"/>
               </a:rPr>
-              <a:t>四、第一次跃迁  v1 → v2a</a:t>
+              <a:t>四、第一次跃迁  Phase 1 → Phase 2</a:t>
             </a:r>
           </a:p>
         </p:txBody>
@@ -13264,7 +13264,7 @@
                 </a:solidFill>
                 <a:latin typeface="Times New Roman"/>
               </a:rPr>
-              <a:t>v1 · STOCKTRANSFORMER</a:t>
+              <a:t>Phase 1 · StockTransformer</a:t>
             </a:r>
           </a:p>
         </p:txBody>
@@ -13518,7 +13518,7 @@
                 </a:solidFill>
                 <a:latin typeface="Times New Roman"/>
               </a:rPr>
-              <a:t>v2a · THREE-MODEL ENSEMBLE</a:t>
+              <a:t>Phase 2 · Three-Model Ensemble</a:t>
             </a:r>
           </a:p>
         </p:txBody>
@@ -14011,7 +14011,7 @@
                 </a:solidFill>
                 <a:latin typeface="Microsoft YaHei"/>
               </a:rPr>
-              <a:t>五、第二次跃迁  v2a → v2b</a:t>
+              <a:t>五、第二次跃迁  Phase 2 → Phase 3</a:t>
             </a:r>
           </a:p>
         </p:txBody>
@@ -14838,7 +14838,7 @@
                 </a:solidFill>
                 <a:latin typeface="Microsoft YaHei"/>
               </a:rPr>
-              <a:t>保留 v2a 全部基础设施</a:t>
+              <a:t>保留 Phase 2 全部基础设施</a:t>
             </a:r>
           </a:p>
           <a:p>
@@ -21161,7 +21161,7 @@
           <a:p>
             <a:pPr algn="l">
               <a:lnSpc>
-                <a:spcPct val="140000"/>
+                <a:spcPct val="125000"/>
               </a:lnSpc>
             </a:pPr>
             <a:r>
@@ -21177,7 +21177,7 @@
           <a:p>
             <a:pPr algn="l">
               <a:lnSpc>
-                <a:spcPct val="140000"/>
+                <a:spcPct val="125000"/>
               </a:lnSpc>
             </a:pPr>
             <a:r>
@@ -21193,7 +21193,7 @@
           <a:p>
             <a:pPr algn="l">
               <a:lnSpc>
-                <a:spcPct val="140000"/>
+                <a:spcPct val="125000"/>
               </a:lnSpc>
             </a:pPr>
             <a:r>

</xml_diff>